<commit_message>
added color for atoms viz
</commit_message>
<xml_diff>
--- a/utils/grip_params_schematic.pptx
+++ b/utils/grip_params_schematic.pptx
@@ -3643,15 +3643,7 @@
             </a:r>
             <a:r>
               <a:rPr lang="en-US" sz="1400" dirty="0"/>
-              <a:t>(</a:t>
-            </a:r>
-            <a:r>
-              <a:rPr lang="en-US" sz="1400"/>
-              <a:t>space between </a:t>
-            </a:r>
-            <a:r>
-              <a:rPr lang="en-US" sz="1400" dirty="0"/>
-              <a:t>slabs)</a:t>
+              <a:t>(space between slabs)</a:t>
             </a:r>
           </a:p>
         </p:txBody>

</xml_diff>